<commit_message>
Fix presentation card overflow
</commit_message>
<xml_diff>
--- a/presentations/calories_zone_conversation_deck.pptx
+++ b/presentations/calories_zone_conversation_deck.pptx
@@ -6207,7 +6207,7 @@
 </file>
 
 <file path=ppt/slides/slide12.xml><?xml version="1.0" encoding="utf-8"?>
-<p:sld xmlns:a="http://schemas.openxmlformats.org/drawingml/2006/main" xmlns:p="http://schemas.openxmlformats.org/presentationml/2006/main" xmlns:r="http://schemas.openxmlformats.org/officeDocument/2006/relationships">
+<p:sld xmlns:a="http://schemas.openxmlformats.org/drawingml/2006/main" xmlns:p="http://schemas.openxmlformats.org/presentationml/2006/main">
   <p:cSld>
     <p:bg>
       <p:bgPr>
@@ -7112,8 +7112,8 @@
         </p:nvSpPr>
         <p:spPr>
           <a:xfrm>
-            <a:off x="868680" y="4892040"/>
-            <a:ext cx="5074920" cy="1051560"/>
+            <a:off x="868680" y="4736592"/>
+            <a:ext cx="5074920" cy="1298448"/>
           </a:xfrm>
           <a:prstGeom prst="roundRect">
             <a:avLst>
@@ -7159,7 +7159,7 @@
         </p:nvSpPr>
         <p:spPr>
           <a:xfrm>
-            <a:off x="1033271" y="5020055"/>
+            <a:off x="1033272" y="4882896"/>
             <a:ext cx="4745736" cy="310896"/>
           </a:xfrm>
           <a:prstGeom prst="rect">
@@ -7194,8 +7194,8 @@
         </p:nvSpPr>
         <p:spPr>
           <a:xfrm>
-            <a:off x="1033271" y="5376672"/>
-            <a:ext cx="4745736" cy="484631"/>
+            <a:off x="1033272" y="5248656"/>
+            <a:ext cx="4745736" cy="685800"/>
           </a:xfrm>
           <a:prstGeom prst="rect">
             <a:avLst/>
@@ -7210,9 +7210,9 @@
           <a:p>
             <a:pPr>
               <a:spcAft>
-                <a:spcPts val="200"/>
+                <a:spcPts val="0"/>
               </a:spcAft>
-              <a:defRPr sz="1150">
+              <a:defRPr sz="1050">
                 <a:solidFill>
                   <a:srgbClr val="1F1D19"/>
                 </a:solidFill>
@@ -7225,9 +7225,9 @@
           <a:p>
             <a:pPr>
               <a:spcAft>
-                <a:spcPts val="200"/>
+                <a:spcPts val="0"/>
               </a:spcAft>
-              <a:defRPr sz="1150">
+              <a:defRPr sz="1050">
                 <a:solidFill>
                   <a:srgbClr val="1F1D19"/>
                 </a:solidFill>
@@ -7247,8 +7247,8 @@
         </p:nvSpPr>
         <p:spPr>
           <a:xfrm>
-            <a:off x="6263640" y="4892040"/>
-            <a:ext cx="5074920" cy="1051560"/>
+            <a:off x="6263640" y="4736592"/>
+            <a:ext cx="5074920" cy="1298448"/>
           </a:xfrm>
           <a:prstGeom prst="roundRect">
             <a:avLst>
@@ -7294,7 +7294,7 @@
         </p:nvSpPr>
         <p:spPr>
           <a:xfrm>
-            <a:off x="6428231" y="5020055"/>
+            <a:off x="6428232" y="4882896"/>
             <a:ext cx="4745736" cy="310896"/>
           </a:xfrm>
           <a:prstGeom prst="rect">
@@ -7329,8 +7329,8 @@
         </p:nvSpPr>
         <p:spPr>
           <a:xfrm>
-            <a:off x="6428231" y="5376672"/>
-            <a:ext cx="4745736" cy="484631"/>
+            <a:off x="6428232" y="5248656"/>
+            <a:ext cx="4745736" cy="685800"/>
           </a:xfrm>
           <a:prstGeom prst="rect">
             <a:avLst/>
@@ -7345,9 +7345,9 @@
           <a:p>
             <a:pPr>
               <a:spcAft>
-                <a:spcPts val="200"/>
+                <a:spcPts val="0"/>
               </a:spcAft>
-              <a:defRPr sz="1150">
+              <a:defRPr sz="1100">
                 <a:solidFill>
                   <a:srgbClr val="1F1D19"/>
                 </a:solidFill>
@@ -7360,9 +7360,9 @@
           <a:p>
             <a:pPr>
               <a:spcAft>
-                <a:spcPts val="200"/>
+                <a:spcPts val="0"/>
               </a:spcAft>
-              <a:defRPr sz="1150">
+              <a:defRPr sz="1100">
                 <a:solidFill>
                   <a:srgbClr val="1F1D19"/>
                 </a:solidFill>

</xml_diff>